<commit_message>
added gpw population into coverage population
</commit_message>
<xml_diff>
--- a/presentations/lrfhss_multibeam_academic_workflow_marp.pptx
+++ b/presentations/lrfhss_multibeam_academic_workflow_marp.pptx
@@ -1309,21 +1309,7 @@
           <a:p>
             <a:r>
               <a:rPr lang="en-US" dirty="0"/>
-              <a:t># Study on NR to Support NTN (TR 38.811)
-### 3GPP
-$$
-\xi_c(t)=\frac{A_{overlap,c}}{A_c}, \quad
-P_{eff}(t)=\sum_c P_c \xi_c(t)
-$$
-- $\xi_c(t)$: fraction of country $c$ covered at time $t$  
-- $A_{overlap,c}$: area of country $c$ inside satellite coverage  
-- $A_c$: total area of country $c$  
-- $P_c$: population assigned to country $c$  
-- $P_{eff}(t)$: effective covered population at time $t$  
-- $\sum_c$: aggregation over all covered countries or cells  
-&lt;!--
-Coverage maps geometry to user distribution.
-Load determines number of active devices.</a:t>
+              <a:t>This slide maps geometric overlap into covered population.</a:t>
             </a:r>
             <a:endParaRPr lang="en-US" dirty="0"/>
           </a:p>
@@ -1587,7 +1573,7 @@
           <a:p>
             <a:r>
               <a:rPr lang="en-US" dirty="0"/>
-              <a:t>This plot supports the channel-quality discussion with measured ECDFs.</a:t>
+              <a:t>This figure shows how successful payload delivery diverges from offered traffic.</a:t>
             </a:r>
             <a:endParaRPr lang="en-US" dirty="0"/>
           </a:p>
@@ -1675,34 +1661,7 @@
           <a:p>
             <a:r>
               <a:rPr lang="en-US" dirty="0"/>
-              <a:t># Study on NR to Support NTN (TR 38.811)
-### 3GPP
-$$
-\mathrm{SINR}=\frac{|h_{u,b^*}|^2}{\sum_{b\neq b^*}|h_{u,b}|^2+N}
-$$
-- $\mathrm{SINR}$: signal-to-interference-plus-noise ratio  
-- $h_{u,b^*}$: channel gain from the serving beam $b^*$ to user $u$  
-- $|h_{u,b^*}|^2$: desired received power from the selected beam  
-- $h_{u,b}$: channel gain from interfering beam $b$ to user $u$  
-- $\sum_{b\neq b^*}|h_{u,b}|^2$: aggregate inter-beam interference power  
-- $b^*$: serving or selected beam index  
-- $N$: receiver noise power  
-&lt;!--
-SINR includes interference from other beams.
-# Enhancing LR-FHSS Scalability Through Advanced Sequence Design and Demodulator Allocation
-### (Diego et al.)
-$$
-Y_{c,t}=f_d(n_{c,t}), \quad
-\gamma_{c,t}=1-\frac{Y_{c,t}}{n_{c,t}}
-$$
-- $n_{c,t}$: number of transmitted packets in cell $c$ at time $t$  
-- $f_d(\cdot)$: decoding function determined by LR-FHSS reception limits  
-- $Y_{c,t}$: number of successfully decoded packets in cell $c$ at time $t$  
-- $\gamma_{c,t}$: collision or packet-loss ratio in cell $c$ at time $t$  
-- $Y_{c,t}/n_{c,t}$: fraction of packets decoded successfully  
-&lt;!--
-Decoding determines successful transmission.
-This figure shows how successful payload delivery diverges from offered traffic.</a:t>
+              <a:t>This plot supports the channel-quality discussion with measured ECDFs.</a:t>
             </a:r>
             <a:endParaRPr lang="en-US" dirty="0"/>
           </a:p>

</xml_diff>

<commit_message>
Coverage Explaination in presentation
</commit_message>
<xml_diff>
--- a/presentations/lrfhss_multibeam_academic_workflow_marp.pptx
+++ b/presentations/lrfhss_multibeam_academic_workflow_marp.pptx
@@ -20,9 +20,11 @@
     <p:sldId id="268" r:id="rId14"/>
     <p:sldId id="269" r:id="rId15"/>
     <p:sldId id="270" r:id="rId16"/>
+    <p:sldId id="271" r:id="rId17"/>
+    <p:sldId id="272" r:id="rId18"/>
   </p:sldIdLst>
   <p:notesMasterIdLst>
-    <p:notesMasterId r:id="rId17"/>
+    <p:notesMasterId r:id="rId19"/>
   </p:notesMasterIdLst>
   <p:sldSz cx="12192000" cy="6858000"/>
   <p:notesSz cx="6858000" cy="12192000"/>
@@ -605,7 +607,7 @@
           <a:p>
             <a:r>
               <a:rPr lang="en-US" dirty="0"/>
-              <a:t>This plot supports the system-level collision discussion.</a:t>
+              <a:t>This plot supports the channel-quality discussion with measured ECDFs.</a:t>
             </a:r>
             <a:endParaRPr lang="en-US" dirty="0"/>
           </a:p>
@@ -693,7 +695,7 @@
           <a:p>
             <a:r>
               <a:rPr lang="en-US" dirty="0"/>
-              <a:t>Power depends on system load.</a:t>
+              <a:t>Collision aggregated across all users.</a:t>
             </a:r>
             <a:endParaRPr lang="en-US" dirty="0"/>
           </a:p>
@@ -781,7 +783,7 @@
           <a:p>
             <a:r>
               <a:rPr lang="en-US" dirty="0"/>
-              <a:t>This plot links decoding saturation to demodulator allocation.</a:t>
+              <a:t>This plot supports the system-level collision discussion.</a:t>
             </a:r>
             <a:endParaRPr lang="en-US" dirty="0"/>
           </a:p>
@@ -869,7 +871,7 @@
           <a:p>
             <a:r>
               <a:rPr lang="en-US" dirty="0"/>
-              <a:t>This plot links congestion events to power draw.</a:t>
+              <a:t>Power depends on system load.</a:t>
             </a:r>
             <a:endParaRPr lang="en-US" dirty="0"/>
           </a:p>
@@ -957,7 +959,7 @@
           <a:p>
             <a:r>
               <a:rPr lang="en-US" dirty="0"/>
-              <a:t/>
+              <a:t>This plot links decoding saturation to demodulator allocation.</a:t>
             </a:r>
             <a:endParaRPr lang="en-US" dirty="0"/>
           </a:p>
@@ -1045,7 +1047,7 @@
           <a:p>
             <a:r>
               <a:rPr lang="en-US" dirty="0"/>
-              <a:t>Left shows contributions, right shows observations.</a:t>
+              <a:t>This plot links congestion events to power draw.</a:t>
             </a:r>
             <a:endParaRPr lang="en-US" dirty="0"/>
           </a:p>
@@ -1087,6 +1089,182 @@
 </p:notes>
 </file>
 
+<file path=ppt/notesSlides/notesSlide16.xml><?xml version="1.0" encoding="utf-8"?>
+<p:notes xmlns:a="http://schemas.openxmlformats.org/drawingml/2006/main" xmlns:r="http://schemas.openxmlformats.org/officeDocument/2006/relationships" xmlns:p="http://schemas.openxmlformats.org/presentationml/2006/main">
+  <p:cSld>
+    <p:spTree>
+      <p:nvGrpSpPr>
+        <p:cNvPr id="1" name=""/>
+        <p:cNvGrpSpPr/>
+        <p:nvPr/>
+      </p:nvGrpSpPr>
+      <p:grpSpPr>
+        <a:xfrm>
+          <a:off x="0" y="0"/>
+          <a:ext cx="0" cy="0"/>
+          <a:chOff x="0" y="0"/>
+          <a:chExt cx="0" cy="0"/>
+        </a:xfrm>
+      </p:grpSpPr>
+      <p:sp>
+        <p:nvSpPr>
+          <p:cNvPr id="2" name="Slide Image Placeholder 1"/>
+          <p:cNvSpPr>
+            <a:spLocks noGrp="1" noRot="1" noChangeAspect="1"/>
+          </p:cNvSpPr>
+          <p:nvPr>
+            <p:ph type="sldImg"/>
+          </p:nvPr>
+        </p:nvSpPr>
+        <p:spPr/>
+      </p:sp>
+      <p:sp>
+        <p:nvSpPr>
+          <p:cNvPr id="3" name="Notes Placeholder 2"/>
+          <p:cNvSpPr>
+            <a:spLocks noGrp="1"/>
+          </p:cNvSpPr>
+          <p:nvPr>
+            <p:ph type="body" idx="1"/>
+          </p:nvPr>
+        </p:nvSpPr>
+        <p:spPr/>
+        <p:txBody>
+          <a:bodyPr/>
+          <a:lstStyle/>
+          <a:p>
+            <a:r>
+              <a:rPr lang="en-US" dirty="0"/>
+              <a:t/>
+            </a:r>
+            <a:endParaRPr lang="en-US" dirty="0"/>
+          </a:p>
+        </p:txBody>
+      </p:sp>
+      <p:sp>
+        <p:nvSpPr>
+          <p:cNvPr id="4" name="Slide Number Placeholder 3"/>
+          <p:cNvSpPr>
+            <a:spLocks noGrp="1"/>
+          </p:cNvSpPr>
+          <p:nvPr>
+            <p:ph type="sldNum" sz="quarter" idx="10"/>
+          </p:nvPr>
+        </p:nvSpPr>
+        <p:spPr/>
+        <p:txBody>
+          <a:bodyPr/>
+          <a:lstStyle/>
+          <a:p>
+            <a:fld id="{F7021451-1387-4CA6-816F-3879F97B5CBC}" type="slidenum">
+              <a:rPr lang="en-US"/>
+              <a:t>16</a:t>
+            </a:fld>
+            <a:endParaRPr lang="en-US"/>
+          </a:p>
+        </p:txBody>
+      </p:sp>
+    </p:spTree>
+    <p:extLst>
+      <p:ext uri="{BB962C8B-B14F-4D97-AF65-F5344CB8AC3E}">
+        <p14:creationId xmlns:p14="http://schemas.microsoft.com/office/powerpoint/2010/main" val="1024086991"/>
+      </p:ext>
+    </p:extLst>
+  </p:cSld>
+  <p:clrMapOvr>
+    <a:masterClrMapping/>
+  </p:clrMapOvr>
+</p:notes>
+</file>
+
+<file path=ppt/notesSlides/notesSlide17.xml><?xml version="1.0" encoding="utf-8"?>
+<p:notes xmlns:a="http://schemas.openxmlformats.org/drawingml/2006/main" xmlns:r="http://schemas.openxmlformats.org/officeDocument/2006/relationships" xmlns:p="http://schemas.openxmlformats.org/presentationml/2006/main">
+  <p:cSld>
+    <p:spTree>
+      <p:nvGrpSpPr>
+        <p:cNvPr id="1" name=""/>
+        <p:cNvGrpSpPr/>
+        <p:nvPr/>
+      </p:nvGrpSpPr>
+      <p:grpSpPr>
+        <a:xfrm>
+          <a:off x="0" y="0"/>
+          <a:ext cx="0" cy="0"/>
+          <a:chOff x="0" y="0"/>
+          <a:chExt cx="0" cy="0"/>
+        </a:xfrm>
+      </p:grpSpPr>
+      <p:sp>
+        <p:nvSpPr>
+          <p:cNvPr id="2" name="Slide Image Placeholder 1"/>
+          <p:cNvSpPr>
+            <a:spLocks noGrp="1" noRot="1" noChangeAspect="1"/>
+          </p:cNvSpPr>
+          <p:nvPr>
+            <p:ph type="sldImg"/>
+          </p:nvPr>
+        </p:nvSpPr>
+        <p:spPr/>
+      </p:sp>
+      <p:sp>
+        <p:nvSpPr>
+          <p:cNvPr id="3" name="Notes Placeholder 2"/>
+          <p:cNvSpPr>
+            <a:spLocks noGrp="1"/>
+          </p:cNvSpPr>
+          <p:nvPr>
+            <p:ph type="body" idx="1"/>
+          </p:nvPr>
+        </p:nvSpPr>
+        <p:spPr/>
+        <p:txBody>
+          <a:bodyPr/>
+          <a:lstStyle/>
+          <a:p>
+            <a:r>
+              <a:rPr lang="en-US" dirty="0"/>
+              <a:t>Left shows contributions, right shows observations.</a:t>
+            </a:r>
+            <a:endParaRPr lang="en-US" dirty="0"/>
+          </a:p>
+        </p:txBody>
+      </p:sp>
+      <p:sp>
+        <p:nvSpPr>
+          <p:cNvPr id="4" name="Slide Number Placeholder 3"/>
+          <p:cNvSpPr>
+            <a:spLocks noGrp="1"/>
+          </p:cNvSpPr>
+          <p:nvPr>
+            <p:ph type="sldNum" sz="quarter" idx="10"/>
+          </p:nvPr>
+        </p:nvSpPr>
+        <p:spPr/>
+        <p:txBody>
+          <a:bodyPr/>
+          <a:lstStyle/>
+          <a:p>
+            <a:fld id="{F7021451-1387-4CA6-816F-3879F97B5CBC}" type="slidenum">
+              <a:rPr lang="en-US"/>
+              <a:t>17</a:t>
+            </a:fld>
+            <a:endParaRPr lang="en-US"/>
+          </a:p>
+        </p:txBody>
+      </p:sp>
+    </p:spTree>
+    <p:extLst>
+      <p:ext uri="{BB962C8B-B14F-4D97-AF65-F5344CB8AC3E}">
+        <p14:creationId xmlns:p14="http://schemas.microsoft.com/office/powerpoint/2010/main" val="1024086991"/>
+      </p:ext>
+    </p:extLst>
+  </p:cSld>
+  <p:clrMapOvr>
+    <a:masterClrMapping/>
+  </p:clrMapOvr>
+</p:notes>
+</file>
+
 <file path=ppt/notesSlides/notesSlide2.xml><?xml version="1.0" encoding="utf-8"?>
 <p:notes xmlns:a="http://schemas.openxmlformats.org/drawingml/2006/main" xmlns:r="http://schemas.openxmlformats.org/officeDocument/2006/relationships" xmlns:p="http://schemas.openxmlformats.org/presentationml/2006/main">
   <p:cSld>
@@ -1133,7 +1311,12 @@
           <a:p>
             <a:r>
               <a:rPr lang="en-US" dirty="0"/>
-              <a:t>Keplerian orbit propagation defines satellite motion.</a:t>
+              <a:t>Our satellite operates in a Low Earth Orbit at 600 km altitude.
+The nearly circular orbit (e=0.001) with near-polar inclination (86.4°) 
+provides global coverage, which is ideal for LEO IoT networks like LoRaWAN.
+With an orbital period of ~97 minutes, the satellite completes roughly 
+15 passes per day. The velocity of 7,560 m/s is typical for LEO constellations.
+This configuration is based on Keplerian propagation with two-body dynamics.</a:t>
             </a:r>
             <a:endParaRPr lang="en-US" dirty="0"/>
           </a:p>
@@ -1221,7 +1404,11 @@
           <a:p>
             <a:r>
               <a:rPr lang="en-US" dirty="0"/>
-              <a:t>Distance varies with geometry and affects signal strength.</a:t>
+              <a:t>Keplerian orbit propagation defines satellite motion.
+The mean motion $n$ depends on the semi-major axis.
+We solve Kepler's equation using Newton-Raphson iteration to find 
+the eccentric anomaly, then compute satellite position in inertial coordinates.
+This propagation is deterministic and highly accurate for our 600 km LEO orbit.</a:t>
             </a:r>
             <a:endParaRPr lang="en-US" dirty="0"/>
           </a:p>
@@ -1309,7 +1496,7 @@
           <a:p>
             <a:r>
               <a:rPr lang="en-US" dirty="0"/>
-              <a:t>This slide maps geometric overlap into covered population.</a:t>
+              <a:t>Distance varies with geometry and affects signal strength.</a:t>
             </a:r>
             <a:endParaRPr lang="en-US" dirty="0"/>
           </a:p>
@@ -1397,7 +1584,7 @@
           <a:p>
             <a:r>
               <a:rPr lang="en-US" dirty="0"/>
-              <a:t>Channel loss depends on distance and environment.</a:t>
+              <a:t/>
             </a:r>
             <a:endParaRPr lang="en-US" dirty="0"/>
           </a:p>
@@ -1485,7 +1672,20 @@
           <a:p>
             <a:r>
               <a:rPr lang="en-US" dirty="0"/>
-              <a:t>SNR defines signal quality baseline.</a:t>
+              <a:t>## Mathematical Model
+$$
+\xi_c(t)=\frac{A_{overlap,c}}{A_c}, \quad
+P_{eff}(t)=\sum_c P_c \, \xi_c(t)
+$$
+**Key Variables:**
+- $A_{overlap,c}$: area where satellite footprint intersects country $c$
+- $A_c$: total area of country $c$  
+- $P_c$: population living in country $c$ (from UN data)
+- $P_{eff}(t)$: effective covered population — the number of people who *can be reached* at time $t$
+- $\xi_c(t)$: coverage factor (0 to 1) — fraction of country $c$ under the satellite at time $t$
+This slide maps geometric overlap into covered population.
+We multiply the coverage fraction by total population to get reachable users.
+The sum over all countries gives the instantaneous effective coverage.</a:t>
             </a:r>
             <a:endParaRPr lang="en-US" dirty="0"/>
           </a:p>
@@ -1573,7 +1773,7 @@
           <a:p>
             <a:r>
               <a:rPr lang="en-US" dirty="0"/>
-              <a:t>This figure shows how successful payload delivery diverges from offered traffic.</a:t>
+              <a:t>Channel loss depends on distance and environment.</a:t>
             </a:r>
             <a:endParaRPr lang="en-US" dirty="0"/>
           </a:p>
@@ -1661,7 +1861,7 @@
           <a:p>
             <a:r>
               <a:rPr lang="en-US" dirty="0"/>
-              <a:t>This plot supports the channel-quality discussion with measured ECDFs.</a:t>
+              <a:t>SNR defines signal quality baseline.</a:t>
             </a:r>
             <a:endParaRPr lang="en-US" dirty="0"/>
           </a:p>
@@ -1749,7 +1949,7 @@
           <a:p>
             <a:r>
               <a:rPr lang="en-US" dirty="0"/>
-              <a:t>Collision aggregated across all users.</a:t>
+              <a:t>This figure shows how successful payload delivery diverges from offered traffic.</a:t>
             </a:r>
             <a:endParaRPr lang="en-US" dirty="0"/>
           </a:p>
@@ -2335,6 +2535,84 @@
 <file path=ppt/slides/slide15.xml><?xml version="1.0" encoding="utf-8"?>
 <p:sld xmlns:a="http://schemas.openxmlformats.org/drawingml/2006/main" xmlns:r="http://schemas.openxmlformats.org/officeDocument/2006/relationships" xmlns:p="http://schemas.openxmlformats.org/presentationml/2006/main">
   <p:cSld name="Slide 15">
+    <p:bg>
+      <p:bgPr>
+        <a:blipFill dpi="0" rotWithShape="1">
+          <a:blip r:embed="rId1">
+            <a:lum/>
+          </a:blip>
+          <a:srcRect/>
+          <a:stretch>
+            <a:fillRect/>
+          </a:stretch>
+        </a:blipFill>
+        <a:effectLst/>
+      </p:bgPr>
+    </p:bg>
+    <p:spTree>
+      <p:nvGrpSpPr>
+        <p:cNvPr id="1" name=""/>
+        <p:cNvGrpSpPr/>
+        <p:nvPr/>
+      </p:nvGrpSpPr>
+      <p:grpSpPr>
+        <a:xfrm>
+          <a:off x="0" y="0"/>
+          <a:ext cx="0" cy="0"/>
+          <a:chOff x="0" y="0"/>
+          <a:chExt cx="0" cy="0"/>
+        </a:xfrm>
+      </p:grpSpPr>
+    </p:spTree>
+  </p:cSld>
+  <p:clrMapOvr>
+    <a:masterClrMapping/>
+  </p:clrMapOvr>
+</p:sld>
+</file>
+
+<file path=ppt/slides/slide16.xml><?xml version="1.0" encoding="utf-8"?>
+<p:sld xmlns:a="http://schemas.openxmlformats.org/drawingml/2006/main" xmlns:r="http://schemas.openxmlformats.org/officeDocument/2006/relationships" xmlns:p="http://schemas.openxmlformats.org/presentationml/2006/main">
+  <p:cSld name="Slide 16">
+    <p:bg>
+      <p:bgPr>
+        <a:blipFill dpi="0" rotWithShape="1">
+          <a:blip r:embed="rId1">
+            <a:lum/>
+          </a:blip>
+          <a:srcRect/>
+          <a:stretch>
+            <a:fillRect/>
+          </a:stretch>
+        </a:blipFill>
+        <a:effectLst/>
+      </p:bgPr>
+    </p:bg>
+    <p:spTree>
+      <p:nvGrpSpPr>
+        <p:cNvPr id="1" name=""/>
+        <p:cNvGrpSpPr/>
+        <p:nvPr/>
+      </p:nvGrpSpPr>
+      <p:grpSpPr>
+        <a:xfrm>
+          <a:off x="0" y="0"/>
+          <a:ext cx="0" cy="0"/>
+          <a:chOff x="0" y="0"/>
+          <a:chExt cx="0" cy="0"/>
+        </a:xfrm>
+      </p:grpSpPr>
+    </p:spTree>
+  </p:cSld>
+  <p:clrMapOvr>
+    <a:masterClrMapping/>
+  </p:clrMapOvr>
+</p:sld>
+</file>
+
+<file path=ppt/slides/slide17.xml><?xml version="1.0" encoding="utf-8"?>
+<p:sld xmlns:a="http://schemas.openxmlformats.org/drawingml/2006/main" xmlns:r="http://schemas.openxmlformats.org/officeDocument/2006/relationships" xmlns:p="http://schemas.openxmlformats.org/presentationml/2006/main">
+  <p:cSld name="Slide 17">
     <p:bg>
       <p:bgPr>
         <a:blipFill dpi="0" rotWithShape="1">

</xml_diff>